<commit_message>
Guía del facilitador completa (v1.2) y alineación de inconsistencias entre fuentes
Co-Authored-By: Claude Opus 5.5 <noreply@anthropic.com>
Claude-Session: https://claude.ai/code/session_01Q1Agik7kXQjPJkwgTZAPZ1
</commit_message>
<xml_diff>
--- a/workshop-liderazgo-intergeneracional/entregables/01_Deck_Liderar_entre_Generaciones_AMMX.pptx
+++ b/workshop-liderazgo-intergeneracional/entregables/01_Deck_Liderar_entre_Generaciones_AMMX.pptx
@@ -565,7 +565,7 @@
               <a:t>CÓMO EXPLICARLA
 PROPÓSITO: Recibir a la sala. La lámina está en pantalla mientras los participantes llegan; no se presenta.
 TIEMPO: Previo al inicio y 0:00–0:02 (palabras de la CHRO).
-GUION DEL FACILITADOR: Sin guion. Los facilitadores saludan en la puerta y dirigen a cada persona a su mesa asignada (la CHRO en una mesa sin reportes directos, D-13). Cada lugar tiene el cuaderno cerrado y el sobre del trabajo previo cerrado.
+GUION DEL FACILITADOR: Sin guion. Los facilitadores saludan en la puerta y dirigen a cada persona a su mesa asignada (la CHRO en una mesa sin reportes directos, D-13). Cada lugar tiene el cuaderno cerrado. Los sobres del trabajo previo los guarda B y los entrega en mano durante el Acto 11 (D-20).
 PUNTOS A CERRAR
 PREGUNTA: —
 RESPUESTA ESPERADA: —
@@ -4312,7 +4312,7 @@
 TRANSICIÓN: B: "Peguen sus hojas en la pared. Galería."
 NOTAS PARA LOS FACILITADORES
 LIDERA: B · A observa y anota qué mesa confundió "adaptar" con "conceder" y qué mesa confundió "firmeza" con "no escuchar" (se usa en el Acto 9).
-CON 4 MESAS: casos A, B, D y E. CON 5: omitir C o F según el perfil de la sala.
+CON 4 MESAS: casos A, B, D y E. CON 5: se agrega el caso C (D-20).
 La CHRO trabaja en su mesa como par; no es la relatora.</a:t>
             </a:r>
             <a:endParaRPr lang="en-US" dirty="0"/>
@@ -41690,7 +41690,7 @@
                 <a:ea typeface="Century Gothic" pitchFamily="34" charset="-122"/>
                 <a:cs typeface="Century Gothic" pitchFamily="34" charset="-120"/>
               </a:rPr>
-              <a:t>Anónima. Tres minutos.</a:t>
+              <a:t>Anónima. Dos minutos.</a:t>
             </a:r>
             <a:endParaRPr lang="en-US" sz="2200" dirty="0"/>
           </a:p>

</xml_diff>